<commit_message>
README: live demo link and hosted-mode notes; deck hosting text
</commit_message>
<xml_diff>
--- a/presentation/Nirikshak.pptx
+++ b/presentation/Nirikshak.pptx
@@ -3355,7 +3355,7 @@
                 </a:solidFill>
                 <a:latin typeface="Inter"/>
               </a:rPr>
-              <a:t>huggingface.co/spaces/…/nirikshak</a:t>
+              <a:t>https://13-233-152-160.sslip.io</a:t>
             </a:r>
           </a:p>
           <a:p>
@@ -3380,7 +3380,7 @@
                 </a:solidFill>
                 <a:latin typeface="Inter"/>
               </a:rPr>
-              <a:t>github.com/RudraPandit0504/nirikshak</a:t>
+              <a:t>https://github.com/RudraPandit0504/nirikshak</a:t>
             </a:r>
           </a:p>
         </p:txBody>
@@ -4761,7 +4761,7 @@
                 </a:solidFill>
                 <a:latin typeface="Inter"/>
               </a:rPr>
-              <a:t>Hosted demo: same code with Google Gemini behind a server-side key and per-visitor limits.</a:t>
+              <a:t>Hosted demo on AWS (EC2, Mumbai): same code, AI via Amazon Bedrock with Groq/Gemini fallback, server-side keys, per-visitor limits.</a:t>
             </a:r>
           </a:p>
           <a:p>
@@ -6216,7 +6216,7 @@
                 </a:solidFill>
                 <a:latin typeface="Inter"/>
               </a:rPr>
-              <a:t>huggingface.co/spaces/…/nirikshak</a:t>
+              <a:t>https://13-233-152-160.sslip.io</a:t>
             </a:r>
           </a:p>
           <a:p>
@@ -6241,7 +6241,7 @@
                 </a:solidFill>
                 <a:latin typeface="Inter"/>
               </a:rPr>
-              <a:t>github.com/RudraPandit0504/nirikshak</a:t>
+              <a:t>https://github.com/RudraPandit0504/nirikshak</a:t>
             </a:r>
           </a:p>
         </p:txBody>

</xml_diff>